<commit_message>
Entrega: relatório/diagramas atualizados + infra de testes (vitest)
- Documentação: relatório renomeado para Relatório_LPEI (odt/pdf), imagens da app,
  poster, diagramas (estado_mesa, tecnologias) e Requisitos.md atualizados.
- Testes: adiciona vitest + lib/pricing.test.ts (14 testes) e vitest.config.ts;
  package.json/lock com a devDependency. Build e testes verdes.
- Remove ficheiro de debug _diag.txt.

Co-Authored-By: Claude Opus 4.8 <noreply@anthropic.com>
</commit_message>
<xml_diff>
--- a/Diagramas, Relatorios, Requisitos/Relatorio e Poster/lpei_poster.pptx
+++ b/Diagramas, Relatorios, Requisitos/Relatorio e Poster/lpei_poster.pptx
@@ -243,7 +243,7 @@
           <a:p>
             <a:fld id="{9010C4FD-9E2D-4F5B-B995-A15615531731}" type="datetimeFigureOut">
               <a:rPr lang="pt-PT" smtClean="0"/>
-              <a:t>11/06/2026</a:t>
+              <a:t>14/06/2026</a:t>
             </a:fld>
             <a:endParaRPr lang="pt-PT"/>
           </a:p>
@@ -413,7 +413,7 @@
           <a:p>
             <a:fld id="{9010C4FD-9E2D-4F5B-B995-A15615531731}" type="datetimeFigureOut">
               <a:rPr lang="pt-PT" smtClean="0"/>
-              <a:t>11/06/2026</a:t>
+              <a:t>14/06/2026</a:t>
             </a:fld>
             <a:endParaRPr lang="pt-PT"/>
           </a:p>
@@ -593,7 +593,7 @@
           <a:p>
             <a:fld id="{9010C4FD-9E2D-4F5B-B995-A15615531731}" type="datetimeFigureOut">
               <a:rPr lang="pt-PT" smtClean="0"/>
-              <a:t>11/06/2026</a:t>
+              <a:t>14/06/2026</a:t>
             </a:fld>
             <a:endParaRPr lang="pt-PT"/>
           </a:p>
@@ -763,7 +763,7 @@
           <a:p>
             <a:fld id="{9010C4FD-9E2D-4F5B-B995-A15615531731}" type="datetimeFigureOut">
               <a:rPr lang="pt-PT" smtClean="0"/>
-              <a:t>11/06/2026</a:t>
+              <a:t>14/06/2026</a:t>
             </a:fld>
             <a:endParaRPr lang="pt-PT"/>
           </a:p>
@@ -1007,7 +1007,7 @@
           <a:p>
             <a:fld id="{9010C4FD-9E2D-4F5B-B995-A15615531731}" type="datetimeFigureOut">
               <a:rPr lang="pt-PT" smtClean="0"/>
-              <a:t>11/06/2026</a:t>
+              <a:t>14/06/2026</a:t>
             </a:fld>
             <a:endParaRPr lang="pt-PT"/>
           </a:p>
@@ -1239,7 +1239,7 @@
           <a:p>
             <a:fld id="{9010C4FD-9E2D-4F5B-B995-A15615531731}" type="datetimeFigureOut">
               <a:rPr lang="pt-PT" smtClean="0"/>
-              <a:t>11/06/2026</a:t>
+              <a:t>14/06/2026</a:t>
             </a:fld>
             <a:endParaRPr lang="pt-PT"/>
           </a:p>
@@ -1606,7 +1606,7 @@
           <a:p>
             <a:fld id="{9010C4FD-9E2D-4F5B-B995-A15615531731}" type="datetimeFigureOut">
               <a:rPr lang="pt-PT" smtClean="0"/>
-              <a:t>11/06/2026</a:t>
+              <a:t>14/06/2026</a:t>
             </a:fld>
             <a:endParaRPr lang="pt-PT"/>
           </a:p>
@@ -1724,7 +1724,7 @@
           <a:p>
             <a:fld id="{9010C4FD-9E2D-4F5B-B995-A15615531731}" type="datetimeFigureOut">
               <a:rPr lang="pt-PT" smtClean="0"/>
-              <a:t>11/06/2026</a:t>
+              <a:t>14/06/2026</a:t>
             </a:fld>
             <a:endParaRPr lang="pt-PT"/>
           </a:p>
@@ -1819,7 +1819,7 @@
           <a:p>
             <a:fld id="{9010C4FD-9E2D-4F5B-B995-A15615531731}" type="datetimeFigureOut">
               <a:rPr lang="pt-PT" smtClean="0"/>
-              <a:t>11/06/2026</a:t>
+              <a:t>14/06/2026</a:t>
             </a:fld>
             <a:endParaRPr lang="pt-PT"/>
           </a:p>
@@ -2096,7 +2096,7 @@
           <a:p>
             <a:fld id="{9010C4FD-9E2D-4F5B-B995-A15615531731}" type="datetimeFigureOut">
               <a:rPr lang="pt-PT" smtClean="0"/>
-              <a:t>11/06/2026</a:t>
+              <a:t>14/06/2026</a:t>
             </a:fld>
             <a:endParaRPr lang="pt-PT"/>
           </a:p>
@@ -2353,7 +2353,7 @@
           <a:p>
             <a:fld id="{9010C4FD-9E2D-4F5B-B995-A15615531731}" type="datetimeFigureOut">
               <a:rPr lang="pt-PT" smtClean="0"/>
-              <a:t>11/06/2026</a:t>
+              <a:t>14/06/2026</a:t>
             </a:fld>
             <a:endParaRPr lang="pt-PT"/>
           </a:p>
@@ -2566,7 +2566,7 @@
           <a:p>
             <a:fld id="{9010C4FD-9E2D-4F5B-B995-A15615531731}" type="datetimeFigureOut">
               <a:rPr lang="pt-PT" smtClean="0"/>
-              <a:t>11/06/2026</a:t>
+              <a:t>14/06/2026</a:t>
             </a:fld>
             <a:endParaRPr lang="pt-PT"/>
           </a:p>
@@ -3384,7 +3384,7 @@
         <p:spPr>
           <a:xfrm>
             <a:off x="1617481" y="9326880"/>
-            <a:ext cx="12344400" cy="27602428"/>
+            <a:ext cx="12344400" cy="29105404"/>
           </a:xfrm>
           <a:prstGeom prst="rect">
             <a:avLst/>
@@ -4154,7 +4154,79 @@
                   <a:srgbClr val="1A1A1A"/>
                 </a:solidFill>
               </a:rPr>
-              <a:t> (full-stack), com base de dados </a:t>
+              <a:t> (</a:t>
+            </a:r>
+            <a:r>
+              <a:rPr lang="en-US" sz="3500" b="0" dirty="0">
+                <a:solidFill>
+                  <a:srgbClr val="1A1A1A"/>
+                </a:solidFill>
+              </a:rPr>
+              <a:t>fra</a:t>
+            </a:r>
+            <a:r>
+              <a:rPr lang="en-US" sz="3500" dirty="0">
+                <a:solidFill>
+                  <a:srgbClr val="1A1A1A"/>
+                </a:solidFill>
+              </a:rPr>
+              <a:t>mework </a:t>
+            </a:r>
+            <a:r>
+              <a:rPr sz="3500" b="0" dirty="0">
+                <a:solidFill>
+                  <a:srgbClr val="1A1A1A"/>
+                </a:solidFill>
+              </a:rPr>
+              <a:t>full-stack),</a:t>
+            </a:r>
+            <a:r>
+              <a:rPr lang="en-US" sz="3500" b="0" dirty="0">
+                <a:solidFill>
+                  <a:srgbClr val="1A1A1A"/>
+                </a:solidFill>
+              </a:rPr>
+              <a:t> num </a:t>
+            </a:r>
+            <a:r>
+              <a:rPr lang="en-US" sz="3500" b="0" dirty="0" err="1">
+                <a:solidFill>
+                  <a:srgbClr val="1A1A1A"/>
+                </a:solidFill>
+              </a:rPr>
+              <a:t>repositório</a:t>
+            </a:r>
+            <a:r>
+              <a:rPr lang="en-US" sz="3500" b="0" dirty="0">
+                <a:solidFill>
+                  <a:srgbClr val="1A1A1A"/>
+                </a:solidFill>
+              </a:rPr>
+              <a:t> </a:t>
+            </a:r>
+            <a:r>
+              <a:rPr lang="en-US" sz="3500" b="1" dirty="0" err="1">
+                <a:solidFill>
+                  <a:srgbClr val="1A1A1A"/>
+                </a:solidFill>
+              </a:rPr>
+              <a:t>Github</a:t>
+            </a:r>
+            <a:r>
+              <a:rPr lang="en-US" sz="3500" dirty="0">
+                <a:solidFill>
+                  <a:srgbClr val="1A1A1A"/>
+                </a:solidFill>
+              </a:rPr>
+              <a:t>, </a:t>
+            </a:r>
+            <a:r>
+              <a:rPr sz="3500" b="0" dirty="0">
+                <a:solidFill>
+                  <a:srgbClr val="1A1A1A"/>
+                </a:solidFill>
+              </a:rPr>
+              <a:t>com base de dados </a:t>
             </a:r>
             <a:r>
               <a:rPr sz="3500" b="1" dirty="0">
@@ -4706,7 +4778,7 @@
             </a:endParaRPr>
           </a:p>
           <a:p>
-            <a:pPr algn="l">
+            <a:pPr>
               <a:spcBef>
                 <a:spcPts val="2000"/>
               </a:spcBef>
@@ -4715,34 +4787,21 @@
               </a:spcAft>
             </a:pPr>
             <a:r>
-              <a:rPr lang="en-US" sz="4600" b="1" dirty="0" err="1">
+              <a:rPr lang="pt-BR" sz="4600" b="1">
                 <a:solidFill>
                   <a:srgbClr val="0F5366"/>
                 </a:solidFill>
               </a:rPr>
-              <a:t>Metodologia</a:t>
-            </a:r>
-            <a:r>
-              <a:rPr lang="en-US" sz="4600" b="1" dirty="0">
-                <a:solidFill>
-                  <a:srgbClr val="0F5366"/>
-                </a:solidFill>
-              </a:rPr>
-              <a:t> — Vibe Coding</a:t>
-            </a:r>
-            <a:endParaRPr sz="4600" b="1" dirty="0">
-              <a:solidFill>
-                <a:srgbClr val="0F5366"/>
-              </a:solidFill>
-            </a:endParaRPr>
-          </a:p>
-          <a:p>
-            <a:pPr algn="l">
+              <a:t>Desenvolvimento assistido por IA orientado por modelos</a:t>
+            </a:r>
+          </a:p>
+          <a:p>
+            <a:pPr>
               <a:spcBef>
-                <a:spcPts val="0"/>
+                <a:spcPts val="2000"/>
               </a:spcBef>
               <a:spcAft>
-                <a:spcPts val="900"/>
+                <a:spcPts val="800"/>
               </a:spcAft>
             </a:pPr>
             <a:r>
@@ -5753,20 +5812,12 @@
               </a:spcAft>
             </a:pPr>
             <a:r>
-              <a:rPr sz="3800" b="0">
-                <a:solidFill>
-                  <a:srgbClr val="1A1A1A"/>
-                </a:solidFill>
-              </a:rPr>
-              <a:t>Frederico </a:t>
-            </a:r>
-            <a:r>
               <a:rPr sz="3800" b="0" dirty="0">
                 <a:solidFill>
                   <a:srgbClr val="1A1A1A"/>
                 </a:solidFill>
               </a:rPr>
-              <a:t>Branco</a:t>
+              <a:t>Frederico Branco</a:t>
             </a:r>
           </a:p>
           <a:p>
@@ -5845,8 +5896,8 @@
         </p:nvSpPr>
         <p:spPr>
           <a:xfrm>
-            <a:off x="16093440" y="32387211"/>
-            <a:ext cx="12344400" cy="4221669"/>
+            <a:off x="15935579" y="31366048"/>
+            <a:ext cx="12344400" cy="4862870"/>
           </a:xfrm>
           <a:prstGeom prst="rect">
             <a:avLst/>
@@ -6264,10 +6315,18 @@
                   <a:srgbClr val="1A1A1A"/>
                 </a:solidFill>
               </a:rPr>
-              <a:t> a </a:t>
-            </a:r>
-            <a:r>
-              <a:rPr sz="3500" b="0" dirty="0" err="1">
+              <a:t> a</a:t>
+            </a:r>
+            <a:r>
+              <a:rPr lang="en-US" sz="3500" b="0" dirty="0">
+                <a:solidFill>
+                  <a:srgbClr val="1A1A1A"/>
+                </a:solidFill>
+              </a:rPr>
+              <a:t> um </a:t>
+            </a:r>
+            <a:r>
+              <a:rPr lang="en-US" sz="3500" b="0" dirty="0" err="1">
                 <a:solidFill>
                   <a:srgbClr val="1A1A1A"/>
                 </a:solidFill>
@@ -6275,13 +6334,65 @@
               <a:t>custo</a:t>
             </a:r>
             <a:r>
-              <a:rPr sz="3500" b="0" dirty="0">
-                <a:solidFill>
-                  <a:srgbClr val="1A1A1A"/>
-                </a:solidFill>
-              </a:rPr>
-              <a:t> zero.</a:t>
-            </a:r>
+              <a:rPr lang="en-US" sz="3500" b="0" dirty="0">
+                <a:solidFill>
+                  <a:srgbClr val="1A1A1A"/>
+                </a:solidFill>
+              </a:rPr>
+              <a:t> </a:t>
+            </a:r>
+            <a:r>
+              <a:rPr lang="en-US" sz="3500" b="0" dirty="0" err="1">
+                <a:solidFill>
+                  <a:srgbClr val="1A1A1A"/>
+                </a:solidFill>
+              </a:rPr>
+              <a:t>bastante</a:t>
+            </a:r>
+            <a:r>
+              <a:rPr lang="en-US" sz="3500" b="0" dirty="0">
+                <a:solidFill>
+                  <a:srgbClr val="1A1A1A"/>
+                </a:solidFill>
+              </a:rPr>
+              <a:t> </a:t>
+            </a:r>
+            <a:r>
+              <a:rPr lang="en-US" sz="3500" b="0">
+                <a:solidFill>
+                  <a:srgbClr val="1A1A1A"/>
+                </a:solidFill>
+              </a:rPr>
+              <a:t>reduzido</a:t>
+            </a:r>
+            <a:r>
+              <a:rPr sz="3500" b="0">
+                <a:solidFill>
+                  <a:srgbClr val="1A1A1A"/>
+                </a:solidFill>
+              </a:rPr>
+              <a:t>.</a:t>
+            </a:r>
+            <a:endParaRPr lang="en-US" sz="3500" b="0" dirty="0">
+              <a:solidFill>
+                <a:srgbClr val="1A1A1A"/>
+              </a:solidFill>
+            </a:endParaRPr>
+          </a:p>
+          <a:p>
+            <a:pPr algn="l">
+              <a:spcBef>
+                <a:spcPts val="0"/>
+              </a:spcBef>
+              <a:spcAft>
+                <a:spcPts val="800"/>
+              </a:spcAft>
+            </a:pPr>
+            <a:endParaRPr sz="3500" b="0" dirty="0">
+              <a:solidFill>
+                <a:srgbClr val="1A1A1A"/>
+              </a:solidFill>
+            </a:endParaRPr>
           </a:p>
           <a:p>
             <a:pPr algn="l">

</xml_diff>